<commit_message>
Stop sessions 9 and 10 telling students the course ends there
Session 9 announced session 10 as 最終回 and session 10 called itself 総仕上げ,
signing off with 全11回、お疲れさまでした — leftovers from the ten-session shape.
Session 10 now points to session 11, and its category label, footers and 総復習
framing read as a mid-course session.

Two survivors are correct as they stand: session 11 calls session 12 最終回, and
session 12 is the 総仕上げ. It is.
</commit_message>
<xml_diff>
--- a/docs/slides/lesson-10.pptx
+++ b/docs/slides/lesson-10.pptx
@@ -1401,7 +1401,7 @@
                 <a:ea typeface="Calibri" pitchFamily="34" charset="-122"/>
                 <a:cs typeface="Calibri" pitchFamily="34" charset="-120"/>
               </a:rPr>
-              <a:t>全13回（デモ＋本編12回）第10回・AI実践・総仕上げ</a:t>
+              <a:t>全13回（デモ＋本編12回）第10回・AI実践</a:t>
             </a:r>
             <a:endParaRPr lang="en-US" sz="1300" dirty="0"/>
           </a:p>
@@ -1545,7 +1545,7 @@
                 <a:ea typeface="Calibri" pitchFamily="34" charset="-122"/>
                 <a:cs typeface="Calibri" pitchFamily="34" charset="-120"/>
               </a:rPr>
-              <a:t>全10回の総仕上げ。思考力とAI実践を統合し、成果物を完成させます。</a:t>
+              <a:t>思考力とAI実践を統合し、成果物を形にします。</a:t>
             </a:r>
             <a:endParaRPr lang="en-US" sz="1300" dirty="0"/>
           </a:p>
@@ -1836,7 +1836,7 @@
                 <a:ea typeface="Calibri" pitchFamily="34" charset="-122"/>
                 <a:cs typeface="Calibri" pitchFamily="34" charset="-120"/>
               </a:rPr>
-              <a:t>最終回では、それを実際に手を動かして体感する</a:t>
+              <a:t>この回では、それを実際に手を動かして体感する</a:t>
             </a:r>
             <a:endParaRPr lang="en-US" sz="1500" dirty="0"/>
           </a:p>
@@ -1875,7 +1875,7 @@
                 <a:ea typeface="Calibri" pitchFamily="34" charset="-122"/>
                 <a:cs typeface="Calibri" pitchFamily="34" charset="-120"/>
               </a:rPr>
-              <a:t>第10回｜自動化・ミニ制作（AI実践・総仕上げ）</a:t>
+              <a:t>第10回｜自動化・ミニ制作（AI実践）</a:t>
             </a:r>
             <a:endParaRPr lang="en-US" sz="1000" dirty="0"/>
           </a:p>
@@ -2364,7 +2364,7 @@
                 <a:ea typeface="Calibri" pitchFamily="34" charset="-122"/>
                 <a:cs typeface="Calibri" pitchFamily="34" charset="-120"/>
               </a:rPr>
-              <a:t>第10回｜自動化・ミニ制作（AI実践・総仕上げ）</a:t>
+              <a:t>第10回｜自動化・ミニ制作（AI実践）</a:t>
             </a:r>
             <a:endParaRPr lang="en-US" sz="1000" dirty="0"/>
           </a:p>
@@ -2435,7 +2435,7 @@
                 <a:ea typeface="Calibri" pitchFamily="34" charset="-122"/>
                 <a:cs typeface="Calibri" pitchFamily="34" charset="-120"/>
               </a:rPr>
-              <a:t>総仕上げ</a:t>
+              <a:t>ここまでの統合</a:t>
             </a:r>
             <a:endParaRPr lang="en-US" sz="1300" dirty="0"/>
           </a:p>
@@ -2474,7 +2474,7 @@
                 <a:ea typeface="Century Schoolbook" pitchFamily="34" charset="-122"/>
                 <a:cs typeface="Century Schoolbook" pitchFamily="34" charset="-120"/>
               </a:rPr>
-              <a:t>問いを立てる→AIに任せる、の総復習。</a:t>
+              <a:t>問いを立てる→AIに任せる、をひと通り通す。</a:t>
             </a:r>
             <a:endParaRPr lang="en-US" sz="2600" dirty="0"/>
           </a:p>
@@ -2770,7 +2770,7 @@
                 <a:ea typeface="Calibri" pitchFamily="34" charset="-122"/>
                 <a:cs typeface="Calibri" pitchFamily="34" charset="-120"/>
               </a:rPr>
-              <a:t>第1回から続けてきた「問いを磨く」姿勢を、最後にもう一度確認する。</a:t>
+              <a:t>第1回から続けてきた「問いを磨く」姿勢を、ここでもう一度確認する。</a:t>
             </a:r>
             <a:endParaRPr lang="en-US" sz="1350" dirty="0"/>
           </a:p>
@@ -2809,7 +2809,7 @@
                 <a:ea typeface="Calibri" pitchFamily="34" charset="-122"/>
                 <a:cs typeface="Calibri" pitchFamily="34" charset="-120"/>
               </a:rPr>
-              <a:t>第10回｜自動化・ミニ制作（AI実践・総仕上げ）</a:t>
+              <a:t>第10回｜自動化・ミニ制作（AI実践）</a:t>
             </a:r>
             <a:endParaRPr lang="en-US" sz="1000" dirty="0"/>
           </a:p>
@@ -3377,7 +3377,7 @@
                 <a:ea typeface="Calibri" pitchFamily="34" charset="-122"/>
                 <a:cs typeface="Calibri" pitchFamily="34" charset="-120"/>
               </a:rPr>
-              <a:t>第10回｜自動化・ミニ制作（AI実践・総仕上げ）</a:t>
+              <a:t>第10回｜自動化・ミニ制作（AI実践）</a:t>
             </a:r>
             <a:endParaRPr lang="en-US" sz="1000" dirty="0"/>
           </a:p>
@@ -3736,7 +3736,7 @@
                 <a:ea typeface="Century Schoolbook" pitchFamily="34" charset="-122"/>
                 <a:cs typeface="Century Schoolbook" pitchFamily="34" charset="-120"/>
               </a:rPr>
-              <a:t>講座修了</a:t>
+              <a:t>次回予告｜第11回：フィードバックを力に変える</a:t>
             </a:r>
             <a:endParaRPr lang="en-US" sz="1800" dirty="0"/>
           </a:p>
@@ -3778,7 +3778,7 @@
                 <a:ea typeface="Calibri" pitchFamily="34" charset="-122"/>
                 <a:cs typeface="Calibri" pitchFamily="34" charset="-120"/>
               </a:rPr>
-              <a:t>全11回、お疲れさまでした。完成した成果物は、ポートフォリオとして今後も磨き続けてください。</a:t>
+              <a:t>他者からの指摘・添削を、次の問いの精度を上げる材料として使う回です。</a:t>
             </a:r>
             <a:endParaRPr lang="en-US" sz="1350" dirty="0"/>
           </a:p>

</xml_diff>